<commit_message>
Repositorio final y presentacion con diapositivas. --v7
</commit_message>
<xml_diff>
--- a/proyecto_final/asistente_financiero/asistente_financiero/Presentacion/DS4-Gloria-Moreno-ProyectoFinal-WebAPI-Presentacion.pptx
+++ b/proyecto_final/asistente_financiero/asistente_financiero/Presentacion/DS4-Gloria-Moreno-ProyectoFinal-WebAPI-Presentacion.pptx
@@ -23120,8 +23120,8 @@
         </p:nvSpPr>
         <p:spPr>
           <a:xfrm>
-            <a:off x="1672199" y="1245150"/>
-            <a:ext cx="6133921" cy="541200"/>
+            <a:off x="1672199" y="1170489"/>
+            <a:ext cx="7290600" cy="541200"/>
           </a:xfrm>
           <a:prstGeom prst="rect">
             <a:avLst/>
@@ -23143,18 +23143,10 @@
               <a:buNone/>
             </a:pPr>
             <a:r>
-              <a:rPr lang="en" dirty="0"/>
-              <a:t>&lt;</a:t>
+              <a:rPr lang="es-PA" sz="1100" dirty="0"/>
+              <a:t>https://github.com/gloria-utp/ds4/tree/Laboratorios/proyecto_final/asistente_financiero/asistente_financiero</a:t>
             </a:r>
-            <a:r>
-              <a:rPr lang="es-PA" dirty="0"/>
-              <a:t>https://github.com/kvinprtugalr/Proyecto1.git</a:t>
-            </a:r>
-            <a:r>
-              <a:rPr lang="en" dirty="0"/>
-              <a:t>&gt;</a:t>
-            </a:r>
-            <a:endParaRPr dirty="0"/>
+            <a:endParaRPr sz="1100" dirty="0"/>
           </a:p>
         </p:txBody>
       </p:sp>
@@ -23415,34 +23407,6 @@
           </p:spPr>
         </p:cxnSp>
       </p:grpSp>
-      <p:pic>
-        <p:nvPicPr>
-          <p:cNvPr id="16" name="Imagen 15">
-            <a:extLst>
-              <a:ext uri="{FF2B5EF4-FFF2-40B4-BE49-F238E27FC236}">
-                <a16:creationId xmlns:a16="http://schemas.microsoft.com/office/drawing/2014/main" id="{C3AAA76A-EF50-4083-A148-E436FDFC951D}"/>
-              </a:ext>
-            </a:extLst>
-          </p:cNvPr>
-          <p:cNvPicPr/>
-          <p:nvPr/>
-        </p:nvPicPr>
-        <p:blipFill>
-          <a:blip r:embed="rId3"/>
-          <a:stretch>
-            <a:fillRect/>
-          </a:stretch>
-        </p:blipFill>
-        <p:spPr>
-          <a:xfrm>
-            <a:off x="2322104" y="1817547"/>
-            <a:ext cx="4932891" cy="2444678"/>
-          </a:xfrm>
-          <a:prstGeom prst="rect">
-            <a:avLst/>
-          </a:prstGeom>
-        </p:spPr>
-      </p:pic>
       <p:sp>
         <p:nvSpPr>
           <p:cNvPr id="2" name="AutoShape 4" descr="Github Icon Logotipo Vector - Descarga Gratis SVG | Worldvectorlogo">
@@ -23503,7 +23467,7 @@
           <p:nvPr/>
         </p:nvPicPr>
         <p:blipFill>
-          <a:blip r:embed="rId4">
+          <a:blip r:embed="rId3">
             <a:extLst>
               <a:ext uri="{28A0092B-C50C-407E-A947-70E740481C1C}">
                 <a14:useLocalDpi xmlns:a14="http://schemas.microsoft.com/office/drawing/2010/main" val="0"/>
@@ -23570,7 +23534,7 @@
             <p:nvPr/>
           </p:nvPicPr>
           <p:blipFill>
-            <a:blip r:embed="rId5">
+            <a:blip r:embed="rId4">
               <a:extLst>
                 <a:ext uri="{28A0092B-C50C-407E-A947-70E740481C1C}">
                   <a14:useLocalDpi xmlns:a14="http://schemas.microsoft.com/office/drawing/2010/main" val="0"/>
@@ -23617,7 +23581,7 @@
             <p:nvPr/>
           </p:nvPicPr>
           <p:blipFill>
-            <a:blip r:embed="rId6">
+            <a:blip r:embed="rId5">
               <a:extLst>
                 <a:ext uri="{28A0092B-C50C-407E-A947-70E740481C1C}">
                   <a14:useLocalDpi xmlns:a14="http://schemas.microsoft.com/office/drawing/2010/main" val="0"/>
@@ -23664,7 +23628,7 @@
             <p:nvPr/>
           </p:nvPicPr>
           <p:blipFill>
-            <a:blip r:embed="rId7">
+            <a:blip r:embed="rId6">
               <a:extLst>
                 <a:ext uri="{28A0092B-C50C-407E-A947-70E740481C1C}">
                   <a14:useLocalDpi xmlns:a14="http://schemas.microsoft.com/office/drawing/2010/main" val="0"/>
@@ -23711,7 +23675,7 @@
             <p:nvPr/>
           </p:nvPicPr>
           <p:blipFill>
-            <a:blip r:embed="rId8">
+            <a:blip r:embed="rId7">
               <a:extLst>
                 <a:ext uri="{28A0092B-C50C-407E-A947-70E740481C1C}">
                   <a14:useLocalDpi xmlns:a14="http://schemas.microsoft.com/office/drawing/2010/main" val="0"/>
@@ -23758,7 +23722,7 @@
             <p:nvPr/>
           </p:nvPicPr>
           <p:blipFill>
-            <a:blip r:embed="rId9">
+            <a:blip r:embed="rId8">
               <a:extLst>
                 <a:ext uri="{28A0092B-C50C-407E-A947-70E740481C1C}">
                   <a14:useLocalDpi xmlns:a14="http://schemas.microsoft.com/office/drawing/2010/main" val="0"/>
@@ -23805,7 +23769,7 @@
             <p:nvPr/>
           </p:nvPicPr>
           <p:blipFill>
-            <a:blip r:embed="rId10">
+            <a:blip r:embed="rId9">
               <a:extLst>
                 <a:ext uri="{28A0092B-C50C-407E-A947-70E740481C1C}">
                   <a14:useLocalDpi xmlns:a14="http://schemas.microsoft.com/office/drawing/2010/main" val="0"/>
@@ -23852,7 +23816,7 @@
             <p:nvPr/>
           </p:nvPicPr>
           <p:blipFill>
-            <a:blip r:embed="rId11">
+            <a:blip r:embed="rId10">
               <a:extLst>
                 <a:ext uri="{28A0092B-C50C-407E-A947-70E740481C1C}">
                   <a14:useLocalDpi xmlns:a14="http://schemas.microsoft.com/office/drawing/2010/main" val="0"/>
@@ -23885,6 +23849,36 @@
           </p:spPr>
         </p:pic>
       </p:grpSp>
+      <p:pic>
+        <p:nvPicPr>
+          <p:cNvPr id="12" name="Picture 11">
+            <a:extLst>
+              <a:ext uri="{FF2B5EF4-FFF2-40B4-BE49-F238E27FC236}">
+                <a16:creationId xmlns:a16="http://schemas.microsoft.com/office/drawing/2014/main" id="{1D15C867-2C07-4F77-7226-140398C0736C}"/>
+              </a:ext>
+            </a:extLst>
+          </p:cNvPr>
+          <p:cNvPicPr>
+            <a:picLocks noChangeAspect="1"/>
+          </p:cNvPicPr>
+          <p:nvPr/>
+        </p:nvPicPr>
+        <p:blipFill>
+          <a:blip r:embed="rId11"/>
+          <a:stretch>
+            <a:fillRect/>
+          </a:stretch>
+        </p:blipFill>
+        <p:spPr>
+          <a:xfrm>
+            <a:off x="1584348" y="1748021"/>
+            <a:ext cx="6280104" cy="2692908"/>
+          </a:xfrm>
+          <a:prstGeom prst="rect">
+            <a:avLst/>
+          </a:prstGeom>
+        </p:spPr>
+      </p:pic>
     </p:spTree>
     <p:extLst>
       <p:ext uri="{BB962C8B-B14F-4D97-AF65-F5344CB8AC3E}">

</xml_diff>